<commit_message>
CMV paper FFT results
</commit_message>
<xml_diff>
--- a/Switching Function - Reduced CMV PWM/Access-paper/Imperix/raw_data/2025.04.23/New Microsoft PowerPoint Presentation.pptx
+++ b/Switching Function - Reduced CMV PWM/Access-paper/Imperix/raw_data/2025.04.23/New Microsoft PowerPoint Presentation.pptx
@@ -6,10 +6,15 @@
   </p:sldMasterIdLst>
   <p:sldIdLst>
     <p:sldId id="264" r:id="rId2"/>
-    <p:sldId id="258" r:id="rId3"/>
-    <p:sldId id="259" r:id="rId4"/>
-    <p:sldId id="261" r:id="rId5"/>
-    <p:sldId id="265" r:id="rId6"/>
+    <p:sldId id="269" r:id="rId3"/>
+    <p:sldId id="258" r:id="rId4"/>
+    <p:sldId id="259" r:id="rId5"/>
+    <p:sldId id="261" r:id="rId6"/>
+    <p:sldId id="265" r:id="rId7"/>
+    <p:sldId id="266" r:id="rId8"/>
+    <p:sldId id="267" r:id="rId9"/>
+    <p:sldId id="270" r:id="rId10"/>
+    <p:sldId id="268" r:id="rId11"/>
   </p:sldIdLst>
   <p:sldSz cx="12192000" cy="6858000"/>
   <p:notesSz cx="6858000" cy="9144000"/>
@@ -247,7 +252,7 @@
           <a:p>
             <a:fld id="{69DDEB30-33BC-43D9-BC16-9E4537202C6A}" type="datetimeFigureOut">
               <a:rPr lang="sv-SE" smtClean="0"/>
-              <a:t>2025-04-24</a:t>
+              <a:t>2025-09-23</a:t>
             </a:fld>
             <a:endParaRPr lang="sv-SE"/>
           </a:p>
@@ -417,7 +422,7 @@
           <a:p>
             <a:fld id="{69DDEB30-33BC-43D9-BC16-9E4537202C6A}" type="datetimeFigureOut">
               <a:rPr lang="sv-SE" smtClean="0"/>
-              <a:t>2025-04-24</a:t>
+              <a:t>2025-09-23</a:t>
             </a:fld>
             <a:endParaRPr lang="sv-SE"/>
           </a:p>
@@ -597,7 +602,7 @@
           <a:p>
             <a:fld id="{69DDEB30-33BC-43D9-BC16-9E4537202C6A}" type="datetimeFigureOut">
               <a:rPr lang="sv-SE" smtClean="0"/>
-              <a:t>2025-04-24</a:t>
+              <a:t>2025-09-23</a:t>
             </a:fld>
             <a:endParaRPr lang="sv-SE"/>
           </a:p>
@@ -767,7 +772,7 @@
           <a:p>
             <a:fld id="{69DDEB30-33BC-43D9-BC16-9E4537202C6A}" type="datetimeFigureOut">
               <a:rPr lang="sv-SE" smtClean="0"/>
-              <a:t>2025-04-24</a:t>
+              <a:t>2025-09-23</a:t>
             </a:fld>
             <a:endParaRPr lang="sv-SE"/>
           </a:p>
@@ -1013,7 +1018,7 @@
           <a:p>
             <a:fld id="{69DDEB30-33BC-43D9-BC16-9E4537202C6A}" type="datetimeFigureOut">
               <a:rPr lang="sv-SE" smtClean="0"/>
-              <a:t>2025-04-24</a:t>
+              <a:t>2025-09-23</a:t>
             </a:fld>
             <a:endParaRPr lang="sv-SE"/>
           </a:p>
@@ -1245,7 +1250,7 @@
           <a:p>
             <a:fld id="{69DDEB30-33BC-43D9-BC16-9E4537202C6A}" type="datetimeFigureOut">
               <a:rPr lang="sv-SE" smtClean="0"/>
-              <a:t>2025-04-24</a:t>
+              <a:t>2025-09-23</a:t>
             </a:fld>
             <a:endParaRPr lang="sv-SE"/>
           </a:p>
@@ -1612,7 +1617,7 @@
           <a:p>
             <a:fld id="{69DDEB30-33BC-43D9-BC16-9E4537202C6A}" type="datetimeFigureOut">
               <a:rPr lang="sv-SE" smtClean="0"/>
-              <a:t>2025-04-24</a:t>
+              <a:t>2025-09-23</a:t>
             </a:fld>
             <a:endParaRPr lang="sv-SE"/>
           </a:p>
@@ -1730,7 +1735,7 @@
           <a:p>
             <a:fld id="{69DDEB30-33BC-43D9-BC16-9E4537202C6A}" type="datetimeFigureOut">
               <a:rPr lang="sv-SE" smtClean="0"/>
-              <a:t>2025-04-24</a:t>
+              <a:t>2025-09-23</a:t>
             </a:fld>
             <a:endParaRPr lang="sv-SE"/>
           </a:p>
@@ -1825,7 +1830,7 @@
           <a:p>
             <a:fld id="{69DDEB30-33BC-43D9-BC16-9E4537202C6A}" type="datetimeFigureOut">
               <a:rPr lang="sv-SE" smtClean="0"/>
-              <a:t>2025-04-24</a:t>
+              <a:t>2025-09-23</a:t>
             </a:fld>
             <a:endParaRPr lang="sv-SE"/>
           </a:p>
@@ -2102,7 +2107,7 @@
           <a:p>
             <a:fld id="{69DDEB30-33BC-43D9-BC16-9E4537202C6A}" type="datetimeFigureOut">
               <a:rPr lang="sv-SE" smtClean="0"/>
-              <a:t>2025-04-24</a:t>
+              <a:t>2025-09-23</a:t>
             </a:fld>
             <a:endParaRPr lang="sv-SE"/>
           </a:p>
@@ -2355,7 +2360,7 @@
           <a:p>
             <a:fld id="{69DDEB30-33BC-43D9-BC16-9E4537202C6A}" type="datetimeFigureOut">
               <a:rPr lang="sv-SE" smtClean="0"/>
-              <a:t>2025-04-24</a:t>
+              <a:t>2025-09-23</a:t>
             </a:fld>
             <a:endParaRPr lang="sv-SE"/>
           </a:p>
@@ -2568,7 +2573,7 @@
           <a:p>
             <a:fld id="{69DDEB30-33BC-43D9-BC16-9E4537202C6A}" type="datetimeFigureOut">
               <a:rPr lang="sv-SE" smtClean="0"/>
-              <a:t>2025-04-24</a:t>
+              <a:t>2025-09-23</a:t>
             </a:fld>
             <a:endParaRPr lang="sv-SE"/>
           </a:p>
@@ -3124,13 +3129,59 @@
         </p:nvPicPr>
         <p:blipFill rotWithShape="1">
           <a:blip r:embed="rId4"/>
-          <a:srcRect l="7334"/>
+          <a:srcRect l="7334" r="7746"/>
           <a:stretch/>
         </p:blipFill>
         <p:spPr>
           <a:xfrm>
             <a:off x="1398270" y="3048000"/>
-            <a:ext cx="8826500" cy="3810000"/>
+            <a:ext cx="8088630" cy="3810000"/>
+          </a:xfrm>
+          <a:prstGeom prst="rect">
+            <a:avLst/>
+          </a:prstGeom>
+        </p:spPr>
+      </p:pic>
+      <p:pic>
+        <p:nvPicPr>
+          <p:cNvPr id="11" name="Picture 10"/>
+          <p:cNvPicPr>
+            <a:picLocks noChangeAspect="1"/>
+          </p:cNvPicPr>
+          <p:nvPr/>
+        </p:nvPicPr>
+        <p:blipFill rotWithShape="1">
+          <a:blip r:embed="rId5"/>
+          <a:srcRect l="79700" t="13500" r="11600" b="53001"/>
+          <a:stretch/>
+        </p:blipFill>
+        <p:spPr>
+          <a:xfrm>
+            <a:off x="8267700" y="309070"/>
+            <a:ext cx="914399" cy="1408385"/>
+          </a:xfrm>
+          <a:prstGeom prst="rect">
+            <a:avLst/>
+          </a:prstGeom>
+        </p:spPr>
+      </p:pic>
+      <p:pic>
+        <p:nvPicPr>
+          <p:cNvPr id="12" name="Picture 11"/>
+          <p:cNvPicPr>
+            <a:picLocks noChangeAspect="1"/>
+          </p:cNvPicPr>
+          <p:nvPr/>
+        </p:nvPicPr>
+        <p:blipFill rotWithShape="1">
+          <a:blip r:embed="rId5"/>
+          <a:srcRect l="79700" t="13500" r="11600" b="53001"/>
+          <a:stretch/>
+        </p:blipFill>
+        <p:spPr>
+          <a:xfrm>
+            <a:off x="8267699" y="3544615"/>
+            <a:ext cx="914399" cy="1408385"/>
           </a:xfrm>
           <a:prstGeom prst="rect">
             <a:avLst/>
@@ -3150,7 +3201,250 @@
 </p:sld>
 </file>
 
+<file path=ppt/slides/slide10.xml><?xml version="1.0" encoding="utf-8"?>
+<p:sld xmlns:a="http://schemas.openxmlformats.org/drawingml/2006/main" xmlns:r="http://schemas.openxmlformats.org/officeDocument/2006/relationships" xmlns:p="http://schemas.openxmlformats.org/presentationml/2006/main">
+  <p:cSld>
+    <p:spTree>
+      <p:nvGrpSpPr>
+        <p:cNvPr id="1" name=""/>
+        <p:cNvGrpSpPr/>
+        <p:nvPr/>
+      </p:nvGrpSpPr>
+      <p:grpSpPr>
+        <a:xfrm>
+          <a:off x="0" y="0"/>
+          <a:ext cx="0" cy="0"/>
+          <a:chOff x="0" y="0"/>
+          <a:chExt cx="0" cy="0"/>
+        </a:xfrm>
+      </p:grpSpPr>
+      <p:pic>
+        <p:nvPicPr>
+          <p:cNvPr id="16" name="Picture 15"/>
+          <p:cNvPicPr>
+            <a:picLocks noChangeAspect="1"/>
+          </p:cNvPicPr>
+          <p:nvPr/>
+        </p:nvPicPr>
+        <p:blipFill>
+          <a:blip r:embed="rId2"/>
+          <a:stretch>
+            <a:fillRect/>
+          </a:stretch>
+        </p:blipFill>
+        <p:spPr>
+          <a:xfrm>
+            <a:off x="1228725" y="571500"/>
+            <a:ext cx="9525000" cy="3810000"/>
+          </a:xfrm>
+          <a:prstGeom prst="rect">
+            <a:avLst/>
+          </a:prstGeom>
+        </p:spPr>
+      </p:pic>
+      <p:sp>
+        <p:nvSpPr>
+          <p:cNvPr id="9" name="Rectangle 8"/>
+          <p:cNvSpPr/>
+          <p:nvPr/>
+        </p:nvSpPr>
+        <p:spPr>
+          <a:xfrm>
+            <a:off x="4117975" y="901823"/>
+            <a:ext cx="2320926" cy="1079378"/>
+          </a:xfrm>
+          <a:prstGeom prst="rect">
+            <a:avLst/>
+          </a:prstGeom>
+          <a:solidFill>
+            <a:schemeClr val="bg1"/>
+          </a:solidFill>
+          <a:ln>
+            <a:solidFill>
+              <a:schemeClr val="bg1"/>
+            </a:solidFill>
+          </a:ln>
+        </p:spPr>
+        <p:style>
+          <a:lnRef idx="2">
+            <a:schemeClr val="accent1">
+              <a:shade val="50000"/>
+            </a:schemeClr>
+          </a:lnRef>
+          <a:fillRef idx="1">
+            <a:schemeClr val="accent1"/>
+          </a:fillRef>
+          <a:effectRef idx="0">
+            <a:schemeClr val="accent1"/>
+          </a:effectRef>
+          <a:fontRef idx="minor">
+            <a:schemeClr val="lt1"/>
+          </a:fontRef>
+        </p:style>
+        <p:txBody>
+          <a:bodyPr rtlCol="0" anchor="ctr"/>
+          <a:lstStyle/>
+          <a:p>
+            <a:pPr algn="ctr"/>
+            <a:endParaRPr lang="sv-SE"/>
+          </a:p>
+        </p:txBody>
+      </p:sp>
+      <p:cxnSp>
+        <p:nvCxnSpPr>
+          <p:cNvPr id="12" name="Straight Arrow Connector 11"/>
+          <p:cNvCxnSpPr/>
+          <p:nvPr/>
+        </p:nvCxnSpPr>
+        <p:spPr>
+          <a:xfrm flipH="1" flipV="1">
+            <a:off x="5416550" y="2051050"/>
+            <a:ext cx="6350" cy="1485900"/>
+          </a:xfrm>
+          <a:prstGeom prst="straightConnector1">
+            <a:avLst/>
+          </a:prstGeom>
+          <a:ln>
+            <a:solidFill>
+              <a:schemeClr val="tx1"/>
+            </a:solidFill>
+            <a:tailEnd type="triangle"/>
+          </a:ln>
+          <a:effectLst>
+            <a:glow rad="63500">
+              <a:schemeClr val="bg1"/>
+            </a:glow>
+          </a:effectLst>
+        </p:spPr>
+        <p:style>
+          <a:lnRef idx="3">
+            <a:schemeClr val="dk1"/>
+          </a:lnRef>
+          <a:fillRef idx="0">
+            <a:schemeClr val="dk1"/>
+          </a:fillRef>
+          <a:effectRef idx="2">
+            <a:schemeClr val="dk1"/>
+          </a:effectRef>
+          <a:fontRef idx="minor">
+            <a:schemeClr val="tx1"/>
+          </a:fontRef>
+        </p:style>
+      </p:cxnSp>
+      <p:pic>
+        <p:nvPicPr>
+          <p:cNvPr id="14" name="Picture 13"/>
+          <p:cNvPicPr>
+            <a:picLocks noChangeAspect="1"/>
+          </p:cNvPicPr>
+          <p:nvPr/>
+        </p:nvPicPr>
+        <p:blipFill rotWithShape="1">
+          <a:blip r:embed="rId3"/>
+          <a:srcRect r="7700"/>
+          <a:stretch/>
+        </p:blipFill>
+        <p:spPr>
+          <a:xfrm>
+            <a:off x="4061983" y="980170"/>
+            <a:ext cx="2309897" cy="1001031"/>
+          </a:xfrm>
+          <a:prstGeom prst="rect">
+            <a:avLst/>
+          </a:prstGeom>
+        </p:spPr>
+      </p:pic>
+      <p:pic>
+        <p:nvPicPr>
+          <p:cNvPr id="17" name="Picture 16"/>
+          <p:cNvPicPr>
+            <a:picLocks noChangeAspect="1"/>
+          </p:cNvPicPr>
+          <p:nvPr/>
+        </p:nvPicPr>
+        <p:blipFill>
+          <a:blip r:embed="rId4"/>
+          <a:stretch>
+            <a:fillRect/>
+          </a:stretch>
+        </p:blipFill>
+        <p:spPr>
+          <a:xfrm>
+            <a:off x="1323975" y="4953000"/>
+            <a:ext cx="9525000" cy="3810000"/>
+          </a:xfrm>
+          <a:prstGeom prst="rect">
+            <a:avLst/>
+          </a:prstGeom>
+        </p:spPr>
+      </p:pic>
+    </p:spTree>
+    <p:extLst>
+      <p:ext uri="{BB962C8B-B14F-4D97-AF65-F5344CB8AC3E}">
+        <p14:creationId xmlns:p14="http://schemas.microsoft.com/office/powerpoint/2010/main" val="1134467441"/>
+      </p:ext>
+    </p:extLst>
+  </p:cSld>
+  <p:clrMapOvr>
+    <a:masterClrMapping/>
+  </p:clrMapOvr>
+</p:sld>
+</file>
+
 <file path=ppt/slides/slide2.xml><?xml version="1.0" encoding="utf-8"?>
+<p:sld xmlns:a="http://schemas.openxmlformats.org/drawingml/2006/main" xmlns:r="http://schemas.openxmlformats.org/officeDocument/2006/relationships" xmlns:p="http://schemas.openxmlformats.org/presentationml/2006/main">
+  <p:cSld>
+    <p:spTree>
+      <p:nvGrpSpPr>
+        <p:cNvPr id="1" name=""/>
+        <p:cNvGrpSpPr/>
+        <p:nvPr/>
+      </p:nvGrpSpPr>
+      <p:grpSpPr>
+        <a:xfrm>
+          <a:off x="0" y="0"/>
+          <a:ext cx="0" cy="0"/>
+          <a:chOff x="0" y="0"/>
+          <a:chExt cx="0" cy="0"/>
+        </a:xfrm>
+      </p:grpSpPr>
+      <p:pic>
+        <p:nvPicPr>
+          <p:cNvPr id="3" name="Picture 2"/>
+          <p:cNvPicPr>
+            <a:picLocks noChangeAspect="1"/>
+          </p:cNvPicPr>
+          <p:nvPr/>
+        </p:nvPicPr>
+        <p:blipFill rotWithShape="1">
+          <a:blip r:embed="rId2"/>
+          <a:srcRect l="79700" t="13500" r="11600" b="53001"/>
+          <a:stretch/>
+        </p:blipFill>
+        <p:spPr>
+          <a:xfrm>
+            <a:off x="8924925" y="2038351"/>
+            <a:ext cx="828675" cy="1276350"/>
+          </a:xfrm>
+          <a:prstGeom prst="rect">
+            <a:avLst/>
+          </a:prstGeom>
+        </p:spPr>
+      </p:pic>
+    </p:spTree>
+    <p:extLst>
+      <p:ext uri="{BB962C8B-B14F-4D97-AF65-F5344CB8AC3E}">
+        <p14:creationId xmlns:p14="http://schemas.microsoft.com/office/powerpoint/2010/main" val="1919384820"/>
+      </p:ext>
+    </p:extLst>
+  </p:cSld>
+  <p:clrMapOvr>
+    <a:masterClrMapping/>
+  </p:clrMapOvr>
+</p:sld>
+</file>
+
+<file path=ppt/slides/slide3.xml><?xml version="1.0" encoding="utf-8"?>
 <p:sld xmlns:a="http://schemas.openxmlformats.org/drawingml/2006/main" xmlns:r="http://schemas.openxmlformats.org/officeDocument/2006/relationships" xmlns:p="http://schemas.openxmlformats.org/presentationml/2006/main">
   <p:cSld>
     <p:spTree>
@@ -3203,207 +3497,6 @@
 </p:sld>
 </file>
 
-<file path=ppt/slides/slide3.xml><?xml version="1.0" encoding="utf-8"?>
-<p:sld xmlns:a="http://schemas.openxmlformats.org/drawingml/2006/main" xmlns:r="http://schemas.openxmlformats.org/officeDocument/2006/relationships" xmlns:p="http://schemas.openxmlformats.org/presentationml/2006/main">
-  <p:cSld>
-    <p:spTree>
-      <p:nvGrpSpPr>
-        <p:cNvPr id="1" name=""/>
-        <p:cNvGrpSpPr/>
-        <p:nvPr/>
-      </p:nvGrpSpPr>
-      <p:grpSpPr>
-        <a:xfrm>
-          <a:off x="0" y="0"/>
-          <a:ext cx="0" cy="0"/>
-          <a:chOff x="0" y="0"/>
-          <a:chExt cx="0" cy="0"/>
-        </a:xfrm>
-      </p:grpSpPr>
-      <p:sp>
-        <p:nvSpPr>
-          <p:cNvPr id="7" name="TextBox 6"/>
-          <p:cNvSpPr txBox="1"/>
-          <p:nvPr/>
-        </p:nvSpPr>
-        <p:spPr>
-          <a:xfrm>
-            <a:off x="5397500" y="2963723"/>
-            <a:ext cx="632460" cy="400110"/>
-          </a:xfrm>
-          <a:prstGeom prst="rect">
-            <a:avLst/>
-          </a:prstGeom>
-          <a:noFill/>
-        </p:spPr>
-        <p:txBody>
-          <a:bodyPr wrap="square" rtlCol="0">
-            <a:spAutoFit/>
-          </a:bodyPr>
-          <a:lstStyle/>
-          <a:p>
-            <a:r>
-              <a:rPr lang="en-US" sz="2000" dirty="0" smtClean="0">
-                <a:latin typeface="Times New Roman" panose="02020603050405020304" pitchFamily="18" charset="0"/>
-                <a:cs typeface="Times New Roman" panose="02020603050405020304" pitchFamily="18" charset="0"/>
-              </a:rPr>
-              <a:t>(a)</a:t>
-            </a:r>
-            <a:endParaRPr lang="sv-SE" sz="2000" dirty="0">
-              <a:latin typeface="Times New Roman" panose="02020603050405020304" pitchFamily="18" charset="0"/>
-              <a:cs typeface="Times New Roman" panose="02020603050405020304" pitchFamily="18" charset="0"/>
-            </a:endParaRPr>
-          </a:p>
-        </p:txBody>
-      </p:sp>
-      <p:sp>
-        <p:nvSpPr>
-          <p:cNvPr id="8" name="TextBox 7"/>
-          <p:cNvSpPr txBox="1"/>
-          <p:nvPr/>
-        </p:nvSpPr>
-        <p:spPr>
-          <a:xfrm>
-            <a:off x="5397500" y="6858000"/>
-            <a:ext cx="632460" cy="400110"/>
-          </a:xfrm>
-          <a:prstGeom prst="rect">
-            <a:avLst/>
-          </a:prstGeom>
-          <a:noFill/>
-        </p:spPr>
-        <p:txBody>
-          <a:bodyPr wrap="square" rtlCol="0">
-            <a:spAutoFit/>
-          </a:bodyPr>
-          <a:lstStyle/>
-          <a:p>
-            <a:r>
-              <a:rPr lang="en-US" sz="2000" dirty="0" smtClean="0">
-                <a:latin typeface="Times New Roman" panose="02020603050405020304" pitchFamily="18" charset="0"/>
-                <a:cs typeface="Times New Roman" panose="02020603050405020304" pitchFamily="18" charset="0"/>
-              </a:rPr>
-              <a:t>(b)</a:t>
-            </a:r>
-            <a:endParaRPr lang="sv-SE" sz="2000" dirty="0">
-              <a:latin typeface="Times New Roman" panose="02020603050405020304" pitchFamily="18" charset="0"/>
-              <a:cs typeface="Times New Roman" panose="02020603050405020304" pitchFamily="18" charset="0"/>
-            </a:endParaRPr>
-          </a:p>
-        </p:txBody>
-      </p:sp>
-      <p:pic>
-        <p:nvPicPr>
-          <p:cNvPr id="6" name="Picture 5"/>
-          <p:cNvPicPr>
-            <a:picLocks noChangeAspect="1"/>
-          </p:cNvPicPr>
-          <p:nvPr/>
-        </p:nvPicPr>
-        <p:blipFill rotWithShape="1">
-          <a:blip r:embed="rId2"/>
-          <a:srcRect l="8500" r="7753"/>
-          <a:stretch/>
-        </p:blipFill>
-        <p:spPr>
-          <a:xfrm>
-            <a:off x="1514475" y="3052763"/>
-            <a:ext cx="7976997" cy="3810000"/>
-          </a:xfrm>
-          <a:prstGeom prst="rect">
-            <a:avLst/>
-          </a:prstGeom>
-        </p:spPr>
-      </p:pic>
-      <p:pic>
-        <p:nvPicPr>
-          <p:cNvPr id="9" name="Picture 8"/>
-          <p:cNvPicPr>
-            <a:picLocks noChangeAspect="1"/>
-          </p:cNvPicPr>
-          <p:nvPr/>
-        </p:nvPicPr>
-        <p:blipFill rotWithShape="1">
-          <a:blip r:embed="rId3"/>
-          <a:srcRect l="4425" r="92336" b="13000"/>
-          <a:stretch/>
-        </p:blipFill>
-        <p:spPr>
-          <a:xfrm>
-            <a:off x="1145381" y="-172897"/>
-            <a:ext cx="308515" cy="3314700"/>
-          </a:xfrm>
-          <a:prstGeom prst="rect">
-            <a:avLst/>
-          </a:prstGeom>
-        </p:spPr>
-      </p:pic>
-      <p:pic>
-        <p:nvPicPr>
-          <p:cNvPr id="11" name="Picture 10"/>
-          <p:cNvPicPr>
-            <a:picLocks noChangeAspect="1"/>
-          </p:cNvPicPr>
-          <p:nvPr/>
-        </p:nvPicPr>
-        <p:blipFill rotWithShape="1">
-          <a:blip r:embed="rId3"/>
-          <a:srcRect l="4425" r="92144" b="13000"/>
-          <a:stretch/>
-        </p:blipFill>
-        <p:spPr>
-          <a:xfrm>
-            <a:off x="1145381" y="3108466"/>
-            <a:ext cx="326803" cy="3314700"/>
-          </a:xfrm>
-          <a:prstGeom prst="rect">
-            <a:avLst/>
-          </a:prstGeom>
-        </p:spPr>
-      </p:pic>
-      <p:pic>
-        <p:nvPicPr>
-          <p:cNvPr id="2" name="Picture 1"/>
-          <p:cNvPicPr>
-            <a:picLocks noChangeAspect="1"/>
-          </p:cNvPicPr>
-          <p:nvPr/>
-        </p:nvPicPr>
-        <p:blipFill rotWithShape="1">
-          <a:blip r:embed="rId4"/>
-          <a:srcRect l="7556" t="5408" r="8792" b="14535"/>
-          <a:stretch/>
-        </p:blipFill>
-        <p:spPr>
-          <a:xfrm>
-            <a:off x="1413573" y="2573"/>
-            <a:ext cx="7967854" cy="3050190"/>
-          </a:xfrm>
-          <a:prstGeom prst="rect">
-            <a:avLst/>
-          </a:prstGeom>
-        </p:spPr>
-      </p:pic>
-    </p:spTree>
-    <p:extLst>
-      <p:ext uri="{BB962C8B-B14F-4D97-AF65-F5344CB8AC3E}">
-        <p14:creationId xmlns:p14="http://schemas.microsoft.com/office/powerpoint/2010/main" val="2519369938"/>
-      </p:ext>
-    </p:extLst>
-  </p:cSld>
-  <p:clrMapOvr>
-    <a:masterClrMapping/>
-  </p:clrMapOvr>
-  <p:timing>
-    <p:tnLst>
-      <p:par>
-        <p:cTn id="1" dur="indefinite" restart="never" nodeType="tmRoot"/>
-      </p:par>
-    </p:tnLst>
-  </p:timing>
-</p:sld>
-</file>
-
 <file path=ppt/slides/slide4.xml><?xml version="1.0" encoding="utf-8"?>
 <p:sld xmlns:a="http://schemas.openxmlformats.org/drawingml/2006/main" xmlns:r="http://schemas.openxmlformats.org/officeDocument/2006/relationships" xmlns:p="http://schemas.openxmlformats.org/presentationml/2006/main">
   <p:cSld>
@@ -3421,6 +3514,29 @@
           <a:chExt cx="0" cy="0"/>
         </a:xfrm>
       </p:grpSpPr>
+      <p:pic>
+        <p:nvPicPr>
+          <p:cNvPr id="11" name="Picture 10"/>
+          <p:cNvPicPr>
+            <a:picLocks noChangeAspect="1"/>
+          </p:cNvPicPr>
+          <p:nvPr/>
+        </p:nvPicPr>
+        <p:blipFill rotWithShape="1">
+          <a:blip r:embed="rId2"/>
+          <a:srcRect l="4425" r="92144" b="13000"/>
+          <a:stretch/>
+        </p:blipFill>
+        <p:spPr>
+          <a:xfrm>
+            <a:off x="1145381" y="3108466"/>
+            <a:ext cx="326803" cy="3314700"/>
+          </a:xfrm>
+          <a:prstGeom prst="rect">
+            <a:avLst/>
+          </a:prstGeom>
+        </p:spPr>
+      </p:pic>
       <p:sp>
         <p:nvSpPr>
           <p:cNvPr id="7" name="TextBox 6"/>
@@ -3493,6 +3609,29 @@
           </a:p>
         </p:txBody>
       </p:sp>
+      <p:pic>
+        <p:nvPicPr>
+          <p:cNvPr id="6" name="Picture 5"/>
+          <p:cNvPicPr>
+            <a:picLocks noChangeAspect="1"/>
+          </p:cNvPicPr>
+          <p:nvPr/>
+        </p:nvPicPr>
+        <p:blipFill rotWithShape="1">
+          <a:blip r:embed="rId3"/>
+          <a:srcRect l="8000" r="7752"/>
+          <a:stretch/>
+        </p:blipFill>
+        <p:spPr>
+          <a:xfrm>
+            <a:off x="1466851" y="3052763"/>
+            <a:ext cx="8024622" cy="3810000"/>
+          </a:xfrm>
+          <a:prstGeom prst="rect">
+            <a:avLst/>
+          </a:prstGeom>
+        </p:spPr>
+      </p:pic>
       <p:pic>
         <p:nvPicPr>
           <p:cNvPr id="9" name="Picture 8"/>
@@ -3518,29 +3657,6 @@
       </p:pic>
       <p:pic>
         <p:nvPicPr>
-          <p:cNvPr id="11" name="Picture 10"/>
-          <p:cNvPicPr>
-            <a:picLocks noChangeAspect="1"/>
-          </p:cNvPicPr>
-          <p:nvPr/>
-        </p:nvPicPr>
-        <p:blipFill rotWithShape="1">
-          <a:blip r:embed="rId2"/>
-          <a:srcRect l="4425" r="92144" b="13000"/>
-          <a:stretch/>
-        </p:blipFill>
-        <p:spPr>
-          <a:xfrm>
-            <a:off x="1145381" y="3108466"/>
-            <a:ext cx="326803" cy="3314700"/>
-          </a:xfrm>
-          <a:prstGeom prst="rect">
-            <a:avLst/>
-          </a:prstGeom>
-        </p:spPr>
-      </p:pic>
-      <p:pic>
-        <p:nvPicPr>
           <p:cNvPr id="2" name="Picture 1"/>
           <p:cNvPicPr>
             <a:picLocks noChangeAspect="1"/>
@@ -3548,7 +3664,7 @@
           <p:nvPr/>
         </p:nvPicPr>
         <p:blipFill rotWithShape="1">
-          <a:blip r:embed="rId3"/>
+          <a:blip r:embed="rId4"/>
           <a:srcRect l="7556" t="5408" r="8792" b="14535"/>
           <a:stretch/>
         </p:blipFill>
@@ -3564,21 +3680,44 @@
       </p:pic>
       <p:pic>
         <p:nvPicPr>
-          <p:cNvPr id="3" name="Picture 2"/>
+          <p:cNvPr id="10" name="Picture 9"/>
           <p:cNvPicPr>
             <a:picLocks noChangeAspect="1"/>
           </p:cNvPicPr>
           <p:nvPr/>
         </p:nvPicPr>
         <p:blipFill rotWithShape="1">
-          <a:blip r:embed="rId4"/>
-          <a:srcRect l="8597" r="7307"/>
+          <a:blip r:embed="rId5"/>
+          <a:srcRect l="79700" t="13500" r="11600" b="53001"/>
           <a:stretch/>
         </p:blipFill>
         <p:spPr>
           <a:xfrm>
-            <a:off x="1545336" y="3108466"/>
-            <a:ext cx="8010144" cy="3810000"/>
+            <a:off x="8248650" y="280495"/>
+            <a:ext cx="914399" cy="1408385"/>
+          </a:xfrm>
+          <a:prstGeom prst="rect">
+            <a:avLst/>
+          </a:prstGeom>
+        </p:spPr>
+      </p:pic>
+      <p:pic>
+        <p:nvPicPr>
+          <p:cNvPr id="12" name="Picture 11"/>
+          <p:cNvPicPr>
+            <a:picLocks noChangeAspect="1"/>
+          </p:cNvPicPr>
+          <p:nvPr/>
+        </p:nvPicPr>
+        <p:blipFill rotWithShape="1">
+          <a:blip r:embed="rId5"/>
+          <a:srcRect l="79700" t="13500" r="11600" b="53001"/>
+          <a:stretch/>
+        </p:blipFill>
+        <p:spPr>
+          <a:xfrm>
+            <a:off x="8248650" y="3546996"/>
+            <a:ext cx="914399" cy="1408385"/>
           </a:xfrm>
           <a:prstGeom prst="rect">
             <a:avLst/>
@@ -3588,7 +3727,7 @@
     </p:spTree>
     <p:extLst>
       <p:ext uri="{BB962C8B-B14F-4D97-AF65-F5344CB8AC3E}">
-        <p14:creationId xmlns:p14="http://schemas.microsoft.com/office/powerpoint/2010/main" val="3734523846"/>
+        <p14:creationId xmlns:p14="http://schemas.microsoft.com/office/powerpoint/2010/main" val="2519369938"/>
       </p:ext>
     </p:extLst>
   </p:cSld>
@@ -3622,6 +3761,253 @@
           <a:chExt cx="0" cy="0"/>
         </a:xfrm>
       </p:grpSpPr>
+      <p:sp>
+        <p:nvSpPr>
+          <p:cNvPr id="7" name="TextBox 6"/>
+          <p:cNvSpPr txBox="1"/>
+          <p:nvPr/>
+        </p:nvSpPr>
+        <p:spPr>
+          <a:xfrm>
+            <a:off x="5397500" y="2963723"/>
+            <a:ext cx="632460" cy="400110"/>
+          </a:xfrm>
+          <a:prstGeom prst="rect">
+            <a:avLst/>
+          </a:prstGeom>
+          <a:noFill/>
+        </p:spPr>
+        <p:txBody>
+          <a:bodyPr wrap="square" rtlCol="0">
+            <a:spAutoFit/>
+          </a:bodyPr>
+          <a:lstStyle/>
+          <a:p>
+            <a:r>
+              <a:rPr lang="en-US" sz="2000" dirty="0" smtClean="0">
+                <a:latin typeface="Times New Roman" panose="02020603050405020304" pitchFamily="18" charset="0"/>
+                <a:cs typeface="Times New Roman" panose="02020603050405020304" pitchFamily="18" charset="0"/>
+              </a:rPr>
+              <a:t>(a)</a:t>
+            </a:r>
+            <a:endParaRPr lang="sv-SE" sz="2000" dirty="0">
+              <a:latin typeface="Times New Roman" panose="02020603050405020304" pitchFamily="18" charset="0"/>
+              <a:cs typeface="Times New Roman" panose="02020603050405020304" pitchFamily="18" charset="0"/>
+            </a:endParaRPr>
+          </a:p>
+        </p:txBody>
+      </p:sp>
+      <p:sp>
+        <p:nvSpPr>
+          <p:cNvPr id="8" name="TextBox 7"/>
+          <p:cNvSpPr txBox="1"/>
+          <p:nvPr/>
+        </p:nvSpPr>
+        <p:spPr>
+          <a:xfrm>
+            <a:off x="5397500" y="6858000"/>
+            <a:ext cx="632460" cy="400110"/>
+          </a:xfrm>
+          <a:prstGeom prst="rect">
+            <a:avLst/>
+          </a:prstGeom>
+          <a:noFill/>
+        </p:spPr>
+        <p:txBody>
+          <a:bodyPr wrap="square" rtlCol="0">
+            <a:spAutoFit/>
+          </a:bodyPr>
+          <a:lstStyle/>
+          <a:p>
+            <a:r>
+              <a:rPr lang="en-US" sz="2000" dirty="0" smtClean="0">
+                <a:latin typeface="Times New Roman" panose="02020603050405020304" pitchFamily="18" charset="0"/>
+                <a:cs typeface="Times New Roman" panose="02020603050405020304" pitchFamily="18" charset="0"/>
+              </a:rPr>
+              <a:t>(b)</a:t>
+            </a:r>
+            <a:endParaRPr lang="sv-SE" sz="2000" dirty="0">
+              <a:latin typeface="Times New Roman" panose="02020603050405020304" pitchFamily="18" charset="0"/>
+              <a:cs typeface="Times New Roman" panose="02020603050405020304" pitchFamily="18" charset="0"/>
+            </a:endParaRPr>
+          </a:p>
+        </p:txBody>
+      </p:sp>
+      <p:pic>
+        <p:nvPicPr>
+          <p:cNvPr id="9" name="Picture 8"/>
+          <p:cNvPicPr>
+            <a:picLocks noChangeAspect="1"/>
+          </p:cNvPicPr>
+          <p:nvPr/>
+        </p:nvPicPr>
+        <p:blipFill rotWithShape="1">
+          <a:blip r:embed="rId2"/>
+          <a:srcRect l="4425" r="92336" b="13000"/>
+          <a:stretch/>
+        </p:blipFill>
+        <p:spPr>
+          <a:xfrm>
+            <a:off x="1145381" y="-172897"/>
+            <a:ext cx="308515" cy="3314700"/>
+          </a:xfrm>
+          <a:prstGeom prst="rect">
+            <a:avLst/>
+          </a:prstGeom>
+        </p:spPr>
+      </p:pic>
+      <p:pic>
+        <p:nvPicPr>
+          <p:cNvPr id="11" name="Picture 10"/>
+          <p:cNvPicPr>
+            <a:picLocks noChangeAspect="1"/>
+          </p:cNvPicPr>
+          <p:nvPr/>
+        </p:nvPicPr>
+        <p:blipFill rotWithShape="1">
+          <a:blip r:embed="rId2"/>
+          <a:srcRect l="4425" r="92144" b="13000"/>
+          <a:stretch/>
+        </p:blipFill>
+        <p:spPr>
+          <a:xfrm>
+            <a:off x="1145381" y="3108466"/>
+            <a:ext cx="326803" cy="3314700"/>
+          </a:xfrm>
+          <a:prstGeom prst="rect">
+            <a:avLst/>
+          </a:prstGeom>
+        </p:spPr>
+      </p:pic>
+      <p:pic>
+        <p:nvPicPr>
+          <p:cNvPr id="2" name="Picture 1"/>
+          <p:cNvPicPr>
+            <a:picLocks noChangeAspect="1"/>
+          </p:cNvPicPr>
+          <p:nvPr/>
+        </p:nvPicPr>
+        <p:blipFill rotWithShape="1">
+          <a:blip r:embed="rId3"/>
+          <a:srcRect l="7556" t="5408" r="8792" b="14535"/>
+          <a:stretch/>
+        </p:blipFill>
+        <p:spPr>
+          <a:xfrm>
+            <a:off x="1413573" y="2573"/>
+            <a:ext cx="7967854" cy="3050190"/>
+          </a:xfrm>
+          <a:prstGeom prst="rect">
+            <a:avLst/>
+          </a:prstGeom>
+        </p:spPr>
+      </p:pic>
+      <p:pic>
+        <p:nvPicPr>
+          <p:cNvPr id="3" name="Picture 2"/>
+          <p:cNvPicPr>
+            <a:picLocks noChangeAspect="1"/>
+          </p:cNvPicPr>
+          <p:nvPr/>
+        </p:nvPicPr>
+        <p:blipFill rotWithShape="1">
+          <a:blip r:embed="rId4"/>
+          <a:srcRect l="8597" r="7307"/>
+          <a:stretch/>
+        </p:blipFill>
+        <p:spPr>
+          <a:xfrm>
+            <a:off x="1545336" y="3108466"/>
+            <a:ext cx="8010144" cy="3810000"/>
+          </a:xfrm>
+          <a:prstGeom prst="rect">
+            <a:avLst/>
+          </a:prstGeom>
+        </p:spPr>
+      </p:pic>
+      <p:pic>
+        <p:nvPicPr>
+          <p:cNvPr id="10" name="Picture 9"/>
+          <p:cNvPicPr>
+            <a:picLocks noChangeAspect="1"/>
+          </p:cNvPicPr>
+          <p:nvPr/>
+        </p:nvPicPr>
+        <p:blipFill rotWithShape="1">
+          <a:blip r:embed="rId5"/>
+          <a:srcRect l="79700" t="13500" r="11600" b="53001"/>
+          <a:stretch/>
+        </p:blipFill>
+        <p:spPr>
+          <a:xfrm>
+            <a:off x="8248650" y="280495"/>
+            <a:ext cx="914399" cy="1408385"/>
+          </a:xfrm>
+          <a:prstGeom prst="rect">
+            <a:avLst/>
+          </a:prstGeom>
+        </p:spPr>
+      </p:pic>
+      <p:pic>
+        <p:nvPicPr>
+          <p:cNvPr id="12" name="Picture 11"/>
+          <p:cNvPicPr>
+            <a:picLocks noChangeAspect="1"/>
+          </p:cNvPicPr>
+          <p:nvPr/>
+        </p:nvPicPr>
+        <p:blipFill rotWithShape="1">
+          <a:blip r:embed="rId5"/>
+          <a:srcRect l="79700" t="13500" r="11600" b="53001"/>
+          <a:stretch/>
+        </p:blipFill>
+        <p:spPr>
+          <a:xfrm>
+            <a:off x="8248650" y="3546996"/>
+            <a:ext cx="914399" cy="1408385"/>
+          </a:xfrm>
+          <a:prstGeom prst="rect">
+            <a:avLst/>
+          </a:prstGeom>
+        </p:spPr>
+      </p:pic>
+    </p:spTree>
+    <p:extLst>
+      <p:ext uri="{BB962C8B-B14F-4D97-AF65-F5344CB8AC3E}">
+        <p14:creationId xmlns:p14="http://schemas.microsoft.com/office/powerpoint/2010/main" val="3734523846"/>
+      </p:ext>
+    </p:extLst>
+  </p:cSld>
+  <p:clrMapOvr>
+    <a:masterClrMapping/>
+  </p:clrMapOvr>
+  <p:timing>
+    <p:tnLst>
+      <p:par>
+        <p:cTn id="1" dur="indefinite" restart="never" nodeType="tmRoot"/>
+      </p:par>
+    </p:tnLst>
+  </p:timing>
+</p:sld>
+</file>
+
+<file path=ppt/slides/slide6.xml><?xml version="1.0" encoding="utf-8"?>
+<p:sld xmlns:a="http://schemas.openxmlformats.org/drawingml/2006/main" xmlns:r="http://schemas.openxmlformats.org/officeDocument/2006/relationships" xmlns:p="http://schemas.openxmlformats.org/presentationml/2006/main">
+  <p:cSld>
+    <p:spTree>
+      <p:nvGrpSpPr>
+        <p:cNvPr id="1" name=""/>
+        <p:cNvGrpSpPr/>
+        <p:nvPr/>
+      </p:nvGrpSpPr>
+      <p:grpSpPr>
+        <a:xfrm>
+          <a:off x="0" y="0"/>
+          <a:ext cx="0" cy="0"/>
+          <a:chOff x="0" y="0"/>
+          <a:chExt cx="0" cy="0"/>
+        </a:xfrm>
+      </p:grpSpPr>
       <p:pic>
         <p:nvPicPr>
           <p:cNvPr id="4" name="Picture 3"/>
@@ -3806,6 +4192,262 @@
     <p:extLst>
       <p:ext uri="{BB962C8B-B14F-4D97-AF65-F5344CB8AC3E}">
         <p14:creationId xmlns:p14="http://schemas.microsoft.com/office/powerpoint/2010/main" val="4177981708"/>
+      </p:ext>
+    </p:extLst>
+  </p:cSld>
+  <p:clrMapOvr>
+    <a:masterClrMapping/>
+  </p:clrMapOvr>
+</p:sld>
+</file>
+
+<file path=ppt/slides/slide7.xml><?xml version="1.0" encoding="utf-8"?>
+<p:sld xmlns:a="http://schemas.openxmlformats.org/drawingml/2006/main" xmlns:r="http://schemas.openxmlformats.org/officeDocument/2006/relationships" xmlns:p="http://schemas.openxmlformats.org/presentationml/2006/main">
+  <p:cSld>
+    <p:spTree>
+      <p:nvGrpSpPr>
+        <p:cNvPr id="1" name=""/>
+        <p:cNvGrpSpPr/>
+        <p:nvPr/>
+      </p:nvGrpSpPr>
+      <p:grpSpPr>
+        <a:xfrm>
+          <a:off x="0" y="0"/>
+          <a:ext cx="0" cy="0"/>
+          <a:chOff x="0" y="0"/>
+          <a:chExt cx="0" cy="0"/>
+        </a:xfrm>
+      </p:grpSpPr>
+      <p:pic>
+        <p:nvPicPr>
+          <p:cNvPr id="4" name="Picture 3"/>
+          <p:cNvPicPr>
+            <a:picLocks noChangeAspect="1"/>
+          </p:cNvPicPr>
+          <p:nvPr/>
+        </p:nvPicPr>
+        <p:blipFill>
+          <a:blip r:embed="rId2"/>
+          <a:stretch>
+            <a:fillRect/>
+          </a:stretch>
+        </p:blipFill>
+        <p:spPr>
+          <a:xfrm>
+            <a:off x="1333500" y="1524000"/>
+            <a:ext cx="9525000" cy="3810000"/>
+          </a:xfrm>
+          <a:prstGeom prst="rect">
+            <a:avLst/>
+          </a:prstGeom>
+        </p:spPr>
+      </p:pic>
+    </p:spTree>
+    <p:extLst>
+      <p:ext uri="{BB962C8B-B14F-4D97-AF65-F5344CB8AC3E}">
+        <p14:creationId xmlns:p14="http://schemas.microsoft.com/office/powerpoint/2010/main" val="575935593"/>
+      </p:ext>
+    </p:extLst>
+  </p:cSld>
+  <p:clrMapOvr>
+    <a:masterClrMapping/>
+  </p:clrMapOvr>
+</p:sld>
+</file>
+
+<file path=ppt/slides/slide8.xml><?xml version="1.0" encoding="utf-8"?>
+<p:sld xmlns:a="http://schemas.openxmlformats.org/drawingml/2006/main" xmlns:r="http://schemas.openxmlformats.org/officeDocument/2006/relationships" xmlns:p="http://schemas.openxmlformats.org/presentationml/2006/main">
+  <p:cSld>
+    <p:spTree>
+      <p:nvGrpSpPr>
+        <p:cNvPr id="1" name=""/>
+        <p:cNvGrpSpPr/>
+        <p:nvPr/>
+      </p:nvGrpSpPr>
+      <p:grpSpPr>
+        <a:xfrm>
+          <a:off x="0" y="0"/>
+          <a:ext cx="0" cy="0"/>
+          <a:chOff x="0" y="0"/>
+          <a:chExt cx="0" cy="0"/>
+        </a:xfrm>
+      </p:grpSpPr>
+      <p:pic>
+        <p:nvPicPr>
+          <p:cNvPr id="4" name="Picture 3"/>
+          <p:cNvPicPr>
+            <a:picLocks noChangeAspect="1"/>
+          </p:cNvPicPr>
+          <p:nvPr/>
+        </p:nvPicPr>
+        <p:blipFill>
+          <a:blip r:embed="rId2"/>
+          <a:stretch>
+            <a:fillRect/>
+          </a:stretch>
+        </p:blipFill>
+        <p:spPr>
+          <a:xfrm>
+            <a:off x="1333500" y="1524000"/>
+            <a:ext cx="9525000" cy="3810000"/>
+          </a:xfrm>
+          <a:prstGeom prst="rect">
+            <a:avLst/>
+          </a:prstGeom>
+        </p:spPr>
+      </p:pic>
+    </p:spTree>
+    <p:extLst>
+      <p:ext uri="{BB962C8B-B14F-4D97-AF65-F5344CB8AC3E}">
+        <p14:creationId xmlns:p14="http://schemas.microsoft.com/office/powerpoint/2010/main" val="2011888469"/>
+      </p:ext>
+    </p:extLst>
+  </p:cSld>
+  <p:clrMapOvr>
+    <a:masterClrMapping/>
+  </p:clrMapOvr>
+</p:sld>
+</file>
+
+<file path=ppt/slides/slide9.xml><?xml version="1.0" encoding="utf-8"?>
+<p:sld xmlns:a="http://schemas.openxmlformats.org/drawingml/2006/main" xmlns:r="http://schemas.openxmlformats.org/officeDocument/2006/relationships" xmlns:p="http://schemas.openxmlformats.org/presentationml/2006/main">
+  <p:cSld>
+    <p:spTree>
+      <p:nvGrpSpPr>
+        <p:cNvPr id="1" name=""/>
+        <p:cNvGrpSpPr/>
+        <p:nvPr/>
+      </p:nvGrpSpPr>
+      <p:grpSpPr>
+        <a:xfrm>
+          <a:off x="0" y="0"/>
+          <a:ext cx="0" cy="0"/>
+          <a:chOff x="0" y="0"/>
+          <a:chExt cx="0" cy="0"/>
+        </a:xfrm>
+      </p:grpSpPr>
+      <p:sp>
+        <p:nvSpPr>
+          <p:cNvPr id="4" name="TextBox 3"/>
+          <p:cNvSpPr txBox="1"/>
+          <p:nvPr/>
+        </p:nvSpPr>
+        <p:spPr>
+          <a:xfrm>
+            <a:off x="5397500" y="1844551"/>
+            <a:ext cx="632460" cy="400110"/>
+          </a:xfrm>
+          <a:prstGeom prst="rect">
+            <a:avLst/>
+          </a:prstGeom>
+          <a:noFill/>
+        </p:spPr>
+        <p:txBody>
+          <a:bodyPr wrap="square" rtlCol="0">
+            <a:spAutoFit/>
+          </a:bodyPr>
+          <a:lstStyle/>
+          <a:p>
+            <a:r>
+              <a:rPr lang="en-US" sz="2000" dirty="0" smtClean="0">
+                <a:latin typeface="Times New Roman" panose="02020603050405020304" pitchFamily="18" charset="0"/>
+                <a:cs typeface="Times New Roman" panose="02020603050405020304" pitchFamily="18" charset="0"/>
+              </a:rPr>
+              <a:t>(a)</a:t>
+            </a:r>
+            <a:endParaRPr lang="sv-SE" sz="2000" dirty="0">
+              <a:latin typeface="Times New Roman" panose="02020603050405020304" pitchFamily="18" charset="0"/>
+              <a:cs typeface="Times New Roman" panose="02020603050405020304" pitchFamily="18" charset="0"/>
+            </a:endParaRPr>
+          </a:p>
+        </p:txBody>
+      </p:sp>
+      <p:sp>
+        <p:nvSpPr>
+          <p:cNvPr id="5" name="TextBox 4"/>
+          <p:cNvSpPr txBox="1"/>
+          <p:nvPr/>
+        </p:nvSpPr>
+        <p:spPr>
+          <a:xfrm>
+            <a:off x="5397500" y="5738828"/>
+            <a:ext cx="632460" cy="400110"/>
+          </a:xfrm>
+          <a:prstGeom prst="rect">
+            <a:avLst/>
+          </a:prstGeom>
+          <a:noFill/>
+        </p:spPr>
+        <p:txBody>
+          <a:bodyPr wrap="square" rtlCol="0">
+            <a:spAutoFit/>
+          </a:bodyPr>
+          <a:lstStyle/>
+          <a:p>
+            <a:r>
+              <a:rPr lang="en-US" sz="2000" dirty="0" smtClean="0">
+                <a:latin typeface="Times New Roman" panose="02020603050405020304" pitchFamily="18" charset="0"/>
+                <a:cs typeface="Times New Roman" panose="02020603050405020304" pitchFamily="18" charset="0"/>
+              </a:rPr>
+              <a:t>(b)</a:t>
+            </a:r>
+            <a:endParaRPr lang="sv-SE" sz="2000" dirty="0">
+              <a:latin typeface="Times New Roman" panose="02020603050405020304" pitchFamily="18" charset="0"/>
+              <a:cs typeface="Times New Roman" panose="02020603050405020304" pitchFamily="18" charset="0"/>
+            </a:endParaRPr>
+          </a:p>
+        </p:txBody>
+      </p:sp>
+      <p:pic>
+        <p:nvPicPr>
+          <p:cNvPr id="6" name="Picture 5"/>
+          <p:cNvPicPr>
+            <a:picLocks noChangeAspect="1"/>
+          </p:cNvPicPr>
+          <p:nvPr/>
+        </p:nvPicPr>
+        <p:blipFill rotWithShape="1">
+          <a:blip r:embed="rId2"/>
+          <a:srcRect l="3333" r="6400"/>
+          <a:stretch/>
+        </p:blipFill>
+        <p:spPr>
+          <a:xfrm>
+            <a:off x="1155700" y="1986717"/>
+            <a:ext cx="8597900" cy="3810000"/>
+          </a:xfrm>
+          <a:prstGeom prst="rect">
+            <a:avLst/>
+          </a:prstGeom>
+        </p:spPr>
+      </p:pic>
+      <p:pic>
+        <p:nvPicPr>
+          <p:cNvPr id="2" name="Picture 1"/>
+          <p:cNvPicPr>
+            <a:picLocks noChangeAspect="1"/>
+          </p:cNvPicPr>
+          <p:nvPr/>
+        </p:nvPicPr>
+        <p:blipFill rotWithShape="1">
+          <a:blip r:embed="rId3"/>
+          <a:srcRect r="7534"/>
+          <a:stretch/>
+        </p:blipFill>
+        <p:spPr>
+          <a:xfrm>
+            <a:off x="692150" y="-1905000"/>
+            <a:ext cx="8807450" cy="3810000"/>
+          </a:xfrm>
+          <a:prstGeom prst="rect">
+            <a:avLst/>
+          </a:prstGeom>
+        </p:spPr>
+      </p:pic>
+    </p:spTree>
+    <p:extLst>
+      <p:ext uri="{BB962C8B-B14F-4D97-AF65-F5344CB8AC3E}">
+        <p14:creationId xmlns:p14="http://schemas.microsoft.com/office/powerpoint/2010/main" val="1689473879"/>
       </p:ext>
     </p:extLst>
   </p:cSld>

</xml_diff>